<commit_message>
Final held-out results (engine v2): benchmark report, ablations, failure analysis, deck with numbers
Co-Authored-By: Claude Opus 5.5 <noreply@anthropic.com>
</commit_message>
<xml_diff>
--- a/submission/VITV_Pokermons_Submission.pptx
+++ b/submission/VITV_Pokermons_Submission.pptx
@@ -13348,7 +13348,7 @@
                 <a:cs typeface="Calibri"/>
                 <a:sym typeface="Calibri"/>
               </a:rPr>
-              <a:t>Submission Github link - (add repo link)</a:t>
+              <a:t>Submission Github link - https://github.com/abhyuday404/DuplexRAG</a:t>
             </a:r>
             <a:endParaRPr/>
           </a:p>
@@ -13684,7 +13684,7 @@
                 </a:solidFill>
                 <a:latin typeface="Calibri"/>
               </a:rPr>
-              <a:t>searches fire mid-sentence and are reused</a:t>
+              <a:t>median 3.2 s head start; searches fire mid-sentence and are reused</a:t>
             </a:r>
           </a:p>
         </p:txBody>
@@ -13827,7 +13827,7 @@
                 </a:solidFill>
                 <a:latin typeface="Calibri"/>
               </a:rPr>
-              <a:t>n/a of claims verified against the cited section; IDs cannot be invented</a:t>
+              <a:t>100% of claims verified against the cited section; IDs cannot be invented</a:t>
             </a:r>
           </a:p>
         </p:txBody>
@@ -14399,7 +14399,7 @@
                 </a:solidFill>
                 <a:latin typeface="Calibri"/>
               </a:rPr>
-              <a:t>discrete-event replay; held-out sets written independently after freezing; the earlier held-out run is reported too</a:t>
+              <a:t>discrete-event replay; each held-out set written independently after a freeze; earlier held-out runs are reported too</a:t>
             </a:r>
           </a:p>
         </p:txBody>
@@ -14542,7 +14542,7 @@
                 <a:cs typeface="Calibri"/>
                 <a:sym typeface="Calibri"/>
               </a:rPr>
-              <a:t>Working prototype code — public or shared GitHub repo (Y): (add public repo link)</a:t>
+              <a:t>Working prototype code — public or shared GitHub repo (Y): https://github.com/abhyuday404/DuplexRAG</a:t>
             </a:r>
             <a:endParaRPr sz="2800"/>
           </a:p>
@@ -16727,94 +16727,33 @@
           </a:p>
         </p:txBody>
       </p:sp>
-      <p:sp>
-        <p:nvSpPr>
-          <p:cNvPr id="120" name="Rounded Rectangle 119"/>
-          <p:cNvSpPr/>
+      <p:pic>
+        <p:nvPicPr>
+          <p:cNvPr id="120" name="Picture 119" descr="ui.png"/>
+          <p:cNvPicPr>
+            <a:picLocks noChangeAspect="1"/>
+          </p:cNvPicPr>
           <p:nvPr/>
-        </p:nvSpPr>
+        </p:nvPicPr>
+        <p:blipFill>
+          <a:blip r:embed="rId3"/>
+          <a:stretch>
+            <a:fillRect/>
+          </a:stretch>
+        </p:blipFill>
         <p:spPr>
           <a:xfrm>
             <a:off x="841248" y="1463040"/>
-            <a:ext cx="6949440" cy="2743200"/>
-          </a:xfrm>
-          <a:prstGeom prst="roundRect">
-            <a:avLst>
-              <a:gd name="adj" fmla="val 8000"/>
-            </a:avLst>
-          </a:prstGeom>
-          <a:solidFill>
-            <a:srgbClr val="F4F1FD"/>
-          </a:solidFill>
-          <a:ln w="12700">
-            <a:solidFill>
-              <a:srgbClr val="D9D4F0"/>
-            </a:solidFill>
-          </a:ln>
-          <a:effectLst/>
-        </p:spPr>
-        <p:style>
-          <a:lnRef idx="1">
-            <a:schemeClr val="accent1"/>
-          </a:lnRef>
-          <a:fillRef idx="3">
-            <a:schemeClr val="accent1"/>
-          </a:fillRef>
-          <a:effectRef idx="2">
-            <a:schemeClr val="accent1"/>
-          </a:effectRef>
-          <a:fontRef idx="minor">
-            <a:schemeClr val="lt1"/>
-          </a:fontRef>
-        </p:style>
-        <p:txBody>
-          <a:bodyPr rtlCol="0" anchor="ctr"/>
-          <a:lstStyle/>
-          <a:p/>
-        </p:txBody>
-      </p:sp>
-      <p:sp>
-        <p:nvSpPr>
-          <p:cNvPr id="121" name="TextBox 120"/>
-          <p:cNvSpPr txBox="1"/>
-          <p:nvPr/>
-        </p:nvSpPr>
-        <p:spPr>
-          <a:xfrm>
-            <a:off x="841248" y="1463040"/>
-            <a:ext cx="6949440" cy="2743200"/>
+            <a:ext cx="6949440" cy="3909060"/>
           </a:xfrm>
           <a:prstGeom prst="rect">
             <a:avLst/>
           </a:prstGeom>
-          <a:noFill/>
-        </p:spPr>
-        <p:txBody>
-          <a:bodyPr wrap="square" anchor="ctr" lIns="45720" rIns="45720">
-            <a:spAutoFit/>
-          </a:bodyPr>
-          <a:lstStyle/>
-          <a:p>
-            <a:pPr algn="l">
-              <a:spcAft>
-                <a:spcPts val="400"/>
-              </a:spcAft>
-            </a:pPr>
-            <a:r>
-              <a:rPr sz="1600" b="0" i="0">
-                <a:solidFill>
-                  <a:srgbClr val="63637E"/>
-                </a:solidFill>
-                <a:latin typeface="Calibri"/>
-              </a:rPr>
-              <a:t>[ui.png missing]</a:t>
-            </a:r>
-          </a:p>
-        </p:txBody>
-      </p:sp>
-      <p:sp>
-        <p:nvSpPr>
-          <p:cNvPr id="122" name="TextBox 121"/>
+        </p:spPr>
+      </p:pic>
+      <p:sp>
+        <p:nvSpPr>
+          <p:cNvPr id="121" name="TextBox 120"/>
           <p:cNvSpPr txBox="1"/>
           <p:nvPr/>
         </p:nvSpPr>
@@ -18381,7 +18320,7 @@
                 </a:solidFill>
                 <a:latin typeface="Calibri"/>
               </a:rPr>
-              <a:t>4 benchmark splits, 3 written independently</a:t>
+              <a:t>4 independently written benchmark splits</a:t>
             </a:r>
           </a:p>
           <a:p>
@@ -19177,7 +19116,7 @@
                 </a:solidFill>
                 <a:latin typeface="Calibri"/>
               </a:rPr>
-              <a:t>n/a</a:t>
+              <a:t>3.2 s</a:t>
             </a:r>
           </a:p>
         </p:txBody>
@@ -19301,7 +19240,7 @@
                 </a:solidFill>
                 <a:latin typeface="Calibri"/>
               </a:rPr>
-              <a:t>n/a</a:t>
+              <a:t>7 ms</a:t>
             </a:r>
           </a:p>
         </p:txBody>
@@ -19425,7 +19364,7 @@
                 </a:solidFill>
                 <a:latin typeface="Calibri"/>
               </a:rPr>
-              <a:t>n/a</a:t>
+              <a:t>614 ms</a:t>
             </a:r>
           </a:p>
         </p:txBody>
@@ -19549,7 +19488,7 @@
                 </a:solidFill>
                 <a:latin typeface="Calibri"/>
               </a:rPr>
-              <a:t>n/a</a:t>
+              <a:t>$0.00007</a:t>
             </a:r>
           </a:p>
         </p:txBody>
@@ -19673,7 +19612,7 @@
                 </a:solidFill>
                 <a:latin typeface="Calibri"/>
               </a:rPr>
-              <a:t>n/a</a:t>
+              <a:t>100%</a:t>
             </a:r>
           </a:p>
         </p:txBody>
@@ -19797,7 +19736,7 @@
                 </a:solidFill>
                 <a:latin typeface="Calibri"/>
               </a:rPr>
-              <a:t>n/a</a:t>
+              <a:t>0</a:t>
             </a:r>
           </a:p>
         </p:txBody>
@@ -20118,7 +20057,7 @@
                           </a:solidFill>
                           <a:latin typeface="Calibri"/>
                         </a:rPr>
-                        <a:t>n/a</a:t>
+                        <a:t>100%</a:t>
                       </a:r>
                     </a:p>
                   </a:txBody>
@@ -20140,7 +20079,7 @@
                           </a:solidFill>
                           <a:latin typeface="Calibri"/>
                         </a:rPr>
-                        <a:t>n/a</a:t>
+                        <a:t>0%</a:t>
                       </a:r>
                     </a:p>
                   </a:txBody>
@@ -20208,7 +20147,7 @@
                           </a:solidFill>
                           <a:latin typeface="Calibri"/>
                         </a:rPr>
-                        <a:t>n/a</a:t>
+                        <a:t>9%</a:t>
                       </a:r>
                     </a:p>
                   </a:txBody>
@@ -20230,7 +20169,7 @@
                           </a:solidFill>
                           <a:latin typeface="Calibri"/>
                         </a:rPr>
-                        <a:t>n/a</a:t>
+                        <a:t>100%</a:t>
                       </a:r>
                     </a:p>
                   </a:txBody>
@@ -20298,7 +20237,7 @@
                           </a:solidFill>
                           <a:latin typeface="Calibri"/>
                         </a:rPr>
-                        <a:t>n/a</a:t>
+                        <a:t>83%</a:t>
                       </a:r>
                     </a:p>
                   </a:txBody>
@@ -20320,7 +20259,7 @@
                           </a:solidFill>
                           <a:latin typeface="Calibri"/>
                         </a:rPr>
-                        <a:t>n/a</a:t>
+                        <a:t>12%</a:t>
                       </a:r>
                     </a:p>
                   </a:txBody>
@@ -20388,7 +20327,7 @@
                           </a:solidFill>
                           <a:latin typeface="Calibri"/>
                         </a:rPr>
-                        <a:t>n/a</a:t>
+                        <a:t>100%</a:t>
                       </a:r>
                     </a:p>
                   </a:txBody>
@@ -20410,7 +20349,7 @@
                           </a:solidFill>
                           <a:latin typeface="Calibri"/>
                         </a:rPr>
-                        <a:t>n/a</a:t>
+                        <a:t>100%</a:t>
                       </a:r>
                     </a:p>
                   </a:txBody>
@@ -20478,7 +20417,7 @@
                           </a:solidFill>
                           <a:latin typeface="Calibri"/>
                         </a:rPr>
-                        <a:t>n/a</a:t>
+                        <a:t>0</a:t>
                       </a:r>
                     </a:p>
                   </a:txBody>
@@ -20500,7 +20439,7 @@
                           </a:solidFill>
                           <a:latin typeface="Calibri"/>
                         </a:rPr>
-                        <a:t>n/a</a:t>
+                        <a:t>0</a:t>
                       </a:r>
                     </a:p>
                   </a:txBody>
@@ -20568,7 +20507,7 @@
                           </a:solidFill>
                           <a:latin typeface="Calibri"/>
                         </a:rPr>
-                        <a:t>n/a</a:t>
+                        <a:t>88%</a:t>
                       </a:r>
                     </a:p>
                   </a:txBody>
@@ -20590,7 +20529,7 @@
                           </a:solidFill>
                           <a:latin typeface="Calibri"/>
                         </a:rPr>
-                        <a:t>n/a</a:t>
+                        <a:t>0%</a:t>
                       </a:r>
                     </a:p>
                   </a:txBody>
@@ -20658,7 +20597,7 @@
                           </a:solidFill>
                           <a:latin typeface="Calibri"/>
                         </a:rPr>
-                        <a:t>n/a</a:t>
+                        <a:t>100%</a:t>
                       </a:r>
                     </a:p>
                   </a:txBody>
@@ -20748,7 +20687,7 @@
                           </a:solidFill>
                           <a:latin typeface="Calibri"/>
                         </a:rPr>
-                        <a:t>n/a</a:t>
+                        <a:t>89%</a:t>
                       </a:r>
                     </a:p>
                   </a:txBody>
@@ -20770,7 +20709,7 @@
                           </a:solidFill>
                           <a:latin typeface="Calibri"/>
                         </a:rPr>
-                        <a:t>n/a</a:t>
+                        <a:t>69%</a:t>
                       </a:r>
                     </a:p>
                   </a:txBody>
@@ -20838,7 +20777,7 @@
                           </a:solidFill>
                           <a:latin typeface="Calibri"/>
                         </a:rPr>
-                        <a:t>n/a</a:t>
+                        <a:t>56%</a:t>
                       </a:r>
                     </a:p>
                   </a:txBody>
@@ -20860,7 +20799,7 @@
                           </a:solidFill>
                           <a:latin typeface="Calibri"/>
                         </a:rPr>
-                        <a:t>n/a</a:t>
+                        <a:t>51%</a:t>
                       </a:r>
                     </a:p>
                   </a:txBody>
@@ -20928,7 +20867,7 @@
                           </a:solidFill>
                           <a:latin typeface="Calibri"/>
                         </a:rPr>
-                        <a:t>n/a</a:t>
+                        <a:t>7 ms</a:t>
                       </a:r>
                     </a:p>
                   </a:txBody>
@@ -20950,7 +20889,7 @@
                           </a:solidFill>
                           <a:latin typeface="Calibri"/>
                         </a:rPr>
-                        <a:t>n/a</a:t>
+                        <a:t>11 ms</a:t>
                       </a:r>
                     </a:p>
                   </a:txBody>

</xml_diff>

<commit_message>
Final submission assets: demo video (3:56) with captions, deck with team members, dated AI disclosure, full benchmark report
Co-Authored-By: Claude Opus 5.5 <noreply@anthropic.com>
</commit_message>
<xml_diff>
--- a/submission/VITV_Pokermons_Submission.pptx
+++ b/submission/VITV_Pokermons_Submission.pptx
@@ -13105,7 +13105,7 @@
         <p:spPr>
           <a:xfrm>
             <a:off x="777240" y="3310128"/>
-            <a:ext cx="5852160" cy="777240"/>
+            <a:ext cx="6263640" cy="777240"/>
           </a:xfrm>
           <a:prstGeom prst="rect">
             <a:avLst/>
@@ -13136,7 +13136,7 @@
               <a:buChar char="•"/>
             </a:pPr>
             <a:r>
-              <a:rPr b="0" i="0" lang="en-US" sz="1600" u="none" cap="none" strike="noStrike">
+              <a:rPr b="0" i="0" lang="en-US" sz="1300" u="none" cap="none" strike="noStrike">
                 <a:solidFill>
                   <a:srgbClr val="63637E"/>
                 </a:solidFill>
@@ -13165,7 +13165,7 @@
               <a:buChar char="•"/>
             </a:pPr>
             <a:r>
-              <a:rPr b="0" i="0" lang="en-US" sz="1600" u="none" cap="none" strike="noStrike">
+              <a:rPr b="0" i="0" lang="en-US" sz="1300" u="none" cap="none" strike="noStrike">
                 <a:solidFill>
                   <a:srgbClr val="63637E"/>
                 </a:solidFill>
@@ -13194,7 +13194,7 @@
               <a:buChar char="•"/>
             </a:pPr>
             <a:r>
-              <a:rPr b="0" i="0" lang="en-US" sz="1600" u="none" cap="none" strike="noStrike">
+              <a:rPr b="0" i="0" lang="en-US" sz="1300" u="none" cap="none" strike="noStrike">
                 <a:solidFill>
                   <a:srgbClr val="63637E"/>
                 </a:solidFill>
@@ -13223,7 +13223,7 @@
               <a:buChar char="•"/>
             </a:pPr>
             <a:r>
-              <a:rPr b="0" i="0" lang="en-US" sz="1600" u="none" cap="none" strike="noStrike">
+              <a:rPr b="0" i="0" lang="en-US" sz="1300" u="none" cap="none" strike="noStrike">
                 <a:solidFill>
                   <a:srgbClr val="63637E"/>
                 </a:solidFill>
@@ -13232,7 +13232,7 @@
                 <a:cs typeface="Calibri"/>
                 <a:sym typeface="Calibri"/>
               </a:rPr>
-              <a:t>Member Name &amp; Email 1- </a:t>
+              <a:t>Member Name &amp; Email 1- Priyank Garg, priyank.garg2024@vitstudent.ac.in</a:t>
             </a:r>
             <a:endParaRPr/>
           </a:p>
@@ -13252,7 +13252,7 @@
               <a:buChar char="•"/>
             </a:pPr>
             <a:r>
-              <a:rPr b="0" i="0" lang="en-US" sz="1600" u="none" cap="none" strike="noStrike">
+              <a:rPr b="0" i="0" lang="en-US" sz="1300" u="none" cap="none" strike="noStrike">
                 <a:solidFill>
                   <a:srgbClr val="63637E"/>
                 </a:solidFill>
@@ -13261,7 +13261,7 @@
                 <a:cs typeface="Calibri"/>
                 <a:sym typeface="Calibri"/>
               </a:rPr>
-              <a:t>Member Name &amp; Email 2- </a:t>
+              <a:t>Member Name &amp; Email 2- Harshit Raj, harshit.raj2025@vitstudent.ac.in</a:t>
             </a:r>
             <a:endParaRPr/>
           </a:p>
@@ -13281,7 +13281,7 @@
               <a:buChar char="•"/>
             </a:pPr>
             <a:r>
-              <a:rPr b="0" i="0" lang="en-US" sz="1600" u="none" cap="none" strike="noStrike">
+              <a:rPr b="0" i="0" lang="en-US" sz="1300" u="none" cap="none" strike="noStrike">
                 <a:solidFill>
                   <a:srgbClr val="63637E"/>
                 </a:solidFill>
@@ -13290,7 +13290,7 @@
                 <a:cs typeface="Calibri"/>
                 <a:sym typeface="Calibri"/>
               </a:rPr>
-              <a:t>Member Name &amp; Email 3- </a:t>
+              <a:t>Member Name &amp; Email 3- Abhyuday Rai, abhyuday.rai2024@vitstudent.ac.in</a:t>
             </a:r>
             <a:endParaRPr/>
           </a:p>
@@ -13310,7 +13310,7 @@
               <a:buChar char="•"/>
             </a:pPr>
             <a:r>
-              <a:rPr b="0" i="0" lang="en-US" sz="1600" u="none" cap="none" strike="noStrike">
+              <a:rPr b="0" i="0" lang="en-US" sz="1300" u="none" cap="none" strike="noStrike">
                 <a:solidFill>
                   <a:srgbClr val="63637E"/>
                 </a:solidFill>
@@ -13339,7 +13339,7 @@
               <a:buChar char="•"/>
             </a:pPr>
             <a:r>
-              <a:rPr b="0" i="0" lang="en-US" sz="1600" u="none" cap="none" strike="noStrike">
+              <a:rPr b="0" i="0" lang="en-US" sz="1300" u="none" cap="none" strike="noStrike">
                 <a:solidFill>
                   <a:srgbClr val="63637E"/>
                 </a:solidFill>
@@ -13368,6 +13368,7 @@
               <a:buNone/>
             </a:pPr>
             <a:r>
+              <a:rPr sz="1300"/>
               <a:t/>
             </a:r>
             <a:endParaRPr b="0" i="0" sz="1600" u="none" cap="none" strike="noStrike">
@@ -13417,8 +13418,8 @@
         </p:nvSpPr>
         <p:spPr>
           <a:xfrm>
-            <a:off x="777240" y="5989320"/>
-            <a:ext cx="6035040" cy="457200"/>
+            <a:off x="777240" y="6309360"/>
+            <a:ext cx="6035040" cy="365760"/>
           </a:xfrm>
           <a:prstGeom prst="rect">
             <a:avLst/>
@@ -13437,7 +13438,7 @@
               </a:spcAft>
             </a:pPr>
             <a:r>
-              <a:rPr sz="1600" b="1" i="0">
+              <a:rPr sz="1300" b="1" i="0">
                 <a:solidFill>
                   <a:srgbClr val="6D28D9"/>
                 </a:solidFill>
@@ -13446,7 +13447,7 @@
               <a:t>DuplexRAG</a:t>
             </a:r>
             <a:r>
-              <a:rPr sz="1600" b="0" i="0">
+              <a:rPr sz="1300" b="0" i="0">
                 <a:solidFill>
                   <a:srgbClr val="63637E"/>
                 </a:solidFill>

</xml_diff>